<commit_message>
analyzer: add tokens-vs-success per-cell scatter slides to deck
Five new slides (one per task) plot median completion tokens vs success%
on a 1x2 (think off/on) grid. Color = arm, marker shape = model; per-arm
lines connect models sorted by x so each line traces the within-arm
correlation between cell verbosity and success across model sizes.

Per-cell aggregation avoids the within-cell difficulty + truncation-cliff
confounds of a binned-by-token curve. Wilson 95% CIs on success%; medians
reuse the existing _completion_median path so the new slides stay
consistent with the bar-chart token slides.
</commit_message>
<xml_diff>
--- a/checkpoints/sweep5-live/pddl_copilot_sweep5_live.pptx
+++ b/checkpoints/sweep5-live/pddl_copilot_sweep5_live.pptx
@@ -10555,7 +10555,7 @@
         <p:spPr>
           <a:xfrm>
             <a:off x="289407" y="685800"/>
-            <a:ext cx="11612880" cy="4261056"/>
+            <a:ext cx="11612880" cy="4143288"/>
           </a:xfrm>
           <a:prstGeom prst="rect">
             <a:avLst/>
@@ -10590,7 +10590,7 @@
                   <a:srgbClr val="444444"/>
                 </a:solidFill>
               </a:rPr>
-              <a:t>Per-cell scatter for `solve`. Each marker = one (model, arm) cell; x = median completion tokens, y = success% with Wilson 95% CI. Lines connect the same model across arms — reads H3 directly: moving along the line from nt-* (circle/diamond) to tl-* (square/triangle) should drop x AND raise y if tools help.</a:t>
+              <a:t>Per-cell scatter for `solve`. Each marker = one (model, arm) cell; color = arm, marker shape = model. Lines connect the 5 model markers WITHIN an arm, sorted by x — so each line traces the within-arm correlation between token spend and success across model sizes. Compare line altitudes: tl-* arms sitting above nt-neut at lower x is the H3 read.</a:t>
             </a:r>
           </a:p>
         </p:txBody>
@@ -10659,7 +10659,7 @@
         <p:spPr>
           <a:xfrm>
             <a:off x="289407" y="685800"/>
-            <a:ext cx="11612880" cy="4020387"/>
+            <a:ext cx="11612880" cy="3916933"/>
           </a:xfrm>
           <a:prstGeom prst="rect">
             <a:avLst/>
@@ -10694,7 +10694,7 @@
                   <a:srgbClr val="444444"/>
                 </a:solidFill>
               </a:rPr>
-              <a:t>Per-cell scatter for `validate_domain`. Same axes/encoding as solve. Note the y range collapses here — most no-tools cells sit at 0–10% success and most with-tools cells sit at 60–95%, with token-budget consumption varying across models more than across arms.</a:t>
+              <a:t>Per-cell scatter for `validate_domain`. Same encoding. Lines connect models within an arm (sorted by x), so the within-arm slope reads as 'do verbose cells do better or worse?' for that condition.</a:t>
             </a:r>
           </a:p>
         </p:txBody>
@@ -10763,7 +10763,7 @@
         <p:spPr>
           <a:xfrm>
             <a:off x="289407" y="685800"/>
-            <a:ext cx="11612880" cy="4004117"/>
+            <a:ext cx="11612880" cy="3901488"/>
           </a:xfrm>
           <a:prstGeom prst="rect">
             <a:avLst/>
@@ -10798,7 +10798,7 @@
                   <a:srgbClr val="444444"/>
                 </a:solidFill>
               </a:rPr>
-              <a:t>Per-cell scatter for `validate_problem`. Look for arms whose marker moves LEFT (fewer tokens) AND UP (more success) — this is the H3 win quadrant.</a:t>
+              <a:t>Per-cell scatter for `validate_problem`. Within-arm correlation across model sizes. The arm whose line sits highest AND leftmost is the Pareto-best configuration on this task.</a:t>
             </a:r>
           </a:p>
         </p:txBody>
@@ -10867,7 +10867,7 @@
         <p:spPr>
           <a:xfrm>
             <a:off x="289407" y="685800"/>
-            <a:ext cx="11612880" cy="4085125"/>
+            <a:ext cx="11612880" cy="3978356"/>
           </a:xfrm>
           <a:prstGeom prst="rect">
             <a:avLst/>
@@ -10902,7 +10902,7 @@
                   <a:srgbClr val="444444"/>
                 </a:solidFill>
               </a:rPr>
-              <a:t>Per-cell scatter for `validate_plan`. Same axes/encoding.</a:t>
+              <a:t>Per-cell scatter for `validate_plan`. Same encoding.</a:t>
             </a:r>
           </a:p>
         </p:txBody>
@@ -10971,7 +10971,7 @@
         <p:spPr>
           <a:xfrm>
             <a:off x="289407" y="685800"/>
-            <a:ext cx="11612880" cy="4185352"/>
+            <a:ext cx="11612880" cy="4073352"/>
           </a:xfrm>
           <a:prstGeom prst="rect">
             <a:avLst/>
@@ -11006,7 +11006,7 @@
                   <a:srgbClr val="444444"/>
                 </a:solidFill>
               </a:rPr>
-              <a:t>Per-cell scatter for `simulate`. The most expensive task per output-token budget; no-tools cells often sit at ~0% across the board (long step-by-step traces). The tools-arm step-down on x is the simulate-tool short-circuit.</a:t>
+              <a:t>Per-cell scatter for `simulate`. The most expensive task per output-token budget; no-tools cells often sit at ~0% across the board (long step-by-step traces). Tools-arm lines vault above the no-tools line at lower x — the simulate-tool short-circuit replacing reasoning.</a:t>
             </a:r>
           </a:p>
         </p:txBody>

</xml_diff>

<commit_message>
complete checkpoint before executing the fourth arem control trial
</commit_message>
<xml_diff>
--- a/checkpoints/sweep5-live/pddl_copilot_sweep5_live.pptx
+++ b/checkpoints/sweep5-live/pddl_copilot_sweep5_live.pptx
@@ -4068,8 +4068,8 @@
         </p:blipFill>
         <p:spPr>
           <a:xfrm>
-            <a:off x="2605979" y="685800"/>
-            <a:ext cx="6979736" cy="5212080"/>
+            <a:off x="834151" y="685800"/>
+            <a:ext cx="10523392" cy="5212080"/>
           </a:xfrm>
           <a:prstGeom prst="rect">
             <a:avLst/>
@@ -11191,7 +11191,7 @@
                     <a:p>
                       <a:r>
                         <a:rPr sz="900"/>
-                        <a:t>2</a:t>
+                        <a:t>3</a:t>
                       </a:r>
                     </a:p>
                   </a:txBody>
@@ -11217,20 +11217,20 @@
                     <a:p>
                       <a:r>
                         <a:rPr sz="900"/>
-                        <a:t>258</a:t>
-                      </a:r>
-                    </a:p>
-                  </a:txBody>
-                  <a:tcPr/>
-                </a:tc>
-                <a:tc>
-                  <a:txBody>
-                    <a:bodyPr/>
-                    <a:lstStyle/>
-                    <a:p>
-                      <a:r>
-                        <a:rPr sz="900"/>
-                        <a:t>2097</a:t>
+                        <a:t>436</a:t>
+                      </a:r>
+                    </a:p>
+                  </a:txBody>
+                  <a:tcPr/>
+                </a:tc>
+                <a:tc>
+                  <a:txBody>
+                    <a:bodyPr/>
+                    <a:lstStyle/>
+                    <a:p>
+                      <a:r>
+                        <a:rPr sz="900"/>
+                        <a:t>2350</a:t>
                       </a:r>
                     </a:p>
                   </a:txBody>
@@ -11269,7 +11269,7 @@
                     <a:p>
                       <a:r>
                         <a:rPr sz="900"/>
-                        <a:t>0.18</a:t>
+                        <a:t>0.21</a:t>
                       </a:r>
                     </a:p>
                   </a:txBody>
@@ -11574,98 +11574,98 @@
                     <a:p>
                       <a:r>
                         <a:rPr sz="900"/>
-                        <a:t>29</a:t>
-                      </a:r>
-                    </a:p>
-                  </a:txBody>
-                  <a:tcPr/>
-                </a:tc>
-                <a:tc>
-                  <a:txBody>
-                    <a:bodyPr/>
-                    <a:lstStyle/>
-                    <a:p>
-                      <a:r>
-                        <a:rPr sz="900"/>
-                        <a:t>0</a:t>
-                      </a:r>
-                    </a:p>
-                  </a:txBody>
-                  <a:tcPr/>
-                </a:tc>
-                <a:tc>
-                  <a:txBody>
-                    <a:bodyPr/>
-                    <a:lstStyle/>
-                    <a:p>
-                      <a:r>
-                        <a:rPr sz="900"/>
-                        <a:t>0</a:t>
-                      </a:r>
-                    </a:p>
-                  </a:txBody>
-                  <a:tcPr/>
-                </a:tc>
-                <a:tc>
-                  <a:txBody>
-                    <a:bodyPr/>
-                    <a:lstStyle/>
-                    <a:p>
-                      <a:r>
-                        <a:rPr sz="900"/>
-                        <a:t>0</a:t>
-                      </a:r>
-                    </a:p>
-                  </a:txBody>
-                  <a:tcPr/>
-                </a:tc>
-                <a:tc>
-                  <a:txBody>
-                    <a:bodyPr/>
-                    <a:lstStyle/>
-                    <a:p>
-                      <a:r>
-                        <a:rPr sz="900"/>
-                        <a:t>214</a:t>
-                      </a:r>
-                    </a:p>
-                  </a:txBody>
-                  <a:tcPr/>
-                </a:tc>
-                <a:tc>
-                  <a:txBody>
-                    <a:bodyPr/>
-                    <a:lstStyle/>
-                    <a:p>
-                      <a:r>
-                        <a:rPr sz="900"/>
-                        <a:t>1.00</a:t>
-                      </a:r>
-                    </a:p>
-                  </a:txBody>
-                  <a:tcPr/>
-                </a:tc>
-                <a:tc>
-                  <a:txBody>
-                    <a:bodyPr/>
-                    <a:lstStyle/>
-                    <a:p>
-                      <a:r>
-                        <a:rPr sz="900"/>
-                        <a:t>1.00</a:t>
-                      </a:r>
-                    </a:p>
-                  </a:txBody>
-                  <a:tcPr/>
-                </a:tc>
-                <a:tc>
-                  <a:txBody>
-                    <a:bodyPr/>
-                    <a:lstStyle/>
-                    <a:p>
-                      <a:r>
-                        <a:rPr sz="900"/>
-                        <a:t>0.12</a:t>
+                        <a:t>132</a:t>
+                      </a:r>
+                    </a:p>
+                  </a:txBody>
+                  <a:tcPr/>
+                </a:tc>
+                <a:tc>
+                  <a:txBody>
+                    <a:bodyPr/>
+                    <a:lstStyle/>
+                    <a:p>
+                      <a:r>
+                        <a:rPr sz="900"/>
+                        <a:t>1</a:t>
+                      </a:r>
+                    </a:p>
+                  </a:txBody>
+                  <a:tcPr/>
+                </a:tc>
+                <a:tc>
+                  <a:txBody>
+                    <a:bodyPr/>
+                    <a:lstStyle/>
+                    <a:p>
+                      <a:r>
+                        <a:rPr sz="900"/>
+                        <a:t>1</a:t>
+                      </a:r>
+                    </a:p>
+                  </a:txBody>
+                  <a:tcPr/>
+                </a:tc>
+                <a:tc>
+                  <a:txBody>
+                    <a:bodyPr/>
+                    <a:lstStyle/>
+                    <a:p>
+                      <a:r>
+                        <a:rPr sz="900"/>
+                        <a:t>177</a:t>
+                      </a:r>
+                    </a:p>
+                  </a:txBody>
+                  <a:tcPr/>
+                </a:tc>
+                <a:tc>
+                  <a:txBody>
+                    <a:bodyPr/>
+                    <a:lstStyle/>
+                    <a:p>
+                      <a:r>
+                        <a:rPr sz="900"/>
+                        <a:t>2689</a:t>
+                      </a:r>
+                    </a:p>
+                  </a:txBody>
+                  <a:tcPr/>
+                </a:tc>
+                <a:tc>
+                  <a:txBody>
+                    <a:bodyPr/>
+                    <a:lstStyle/>
+                    <a:p>
+                      <a:r>
+                        <a:rPr sz="900"/>
+                        <a:t>0.99</a:t>
+                      </a:r>
+                    </a:p>
+                  </a:txBody>
+                  <a:tcPr/>
+                </a:tc>
+                <a:tc>
+                  <a:txBody>
+                    <a:bodyPr/>
+                    <a:lstStyle/>
+                    <a:p>
+                      <a:r>
+                        <a:rPr sz="900"/>
+                        <a:t>0.99</a:t>
+                      </a:r>
+                    </a:p>
+                  </a:txBody>
+                  <a:tcPr/>
+                </a:tc>
+                <a:tc>
+                  <a:txBody>
+                    <a:bodyPr/>
+                    <a:lstStyle/>
+                    <a:p>
+                      <a:r>
+                        <a:rPr sz="900"/>
+                        <a:t>0.10</a:t>
                       </a:r>
                     </a:p>
                   </a:txBody>
@@ -13464,7 +13464,7 @@
                     <a:p>
                       <a:r>
                         <a:rPr sz="900"/>
-                        <a:t>0</a:t>
+                        <a:t>17</a:t>
                       </a:r>
                     </a:p>
                   </a:txBody>
@@ -13490,33 +13490,33 @@
                     <a:p>
                       <a:r>
                         <a:rPr sz="900"/>
-                        <a:t>459</a:t>
-                      </a:r>
-                    </a:p>
-                  </a:txBody>
-                  <a:tcPr/>
-                </a:tc>
-                <a:tc>
-                  <a:txBody>
-                    <a:bodyPr/>
-                    <a:lstStyle/>
-                    <a:p>
-                      <a:r>
-                        <a:rPr sz="900"/>
-                        <a:t>706</a:t>
-                      </a:r>
-                    </a:p>
-                  </a:txBody>
-                  <a:tcPr/>
-                </a:tc>
-                <a:tc>
-                  <a:txBody>
-                    <a:bodyPr/>
-                    <a:lstStyle/>
-                    <a:p>
-                      <a:r>
-                        <a:rPr sz="900"/>
-                        <a:t>1.00</a:t>
+                        <a:t>1059</a:t>
+                      </a:r>
+                    </a:p>
+                  </a:txBody>
+                  <a:tcPr/>
+                </a:tc>
+                <a:tc>
+                  <a:txBody>
+                    <a:bodyPr/>
+                    <a:lstStyle/>
+                    <a:p>
+                      <a:r>
+                        <a:rPr sz="900"/>
+                        <a:t>963</a:t>
+                      </a:r>
+                    </a:p>
+                  </a:txBody>
+                  <a:tcPr/>
+                </a:tc>
+                <a:tc>
+                  <a:txBody>
+                    <a:bodyPr/>
+                    <a:lstStyle/>
+                    <a:p>
+                      <a:r>
+                        <a:rPr sz="900"/>
+                        <a:t>0.98</a:t>
                       </a:r>
                     </a:p>
                   </a:txBody>
@@ -13542,7 +13542,7 @@
                     <a:p>
                       <a:r>
                         <a:rPr sz="900"/>
-                        <a:t>0.64</a:t>
+                        <a:t>0.65</a:t>
                       </a:r>
                     </a:p>
                   </a:txBody>
@@ -15558,7 +15558,7 @@
                   <a:srgbClr val="FFFFFF"/>
                 </a:solidFill>
               </a:rPr>
-              <a:t>Qwen3.5-9B · no simulate trials in this cell</a:t>
+              <a:t>Qwen3.5-9B  ·  failure_reason = think_overflow  (200/300 simulate trials, 67%)  ·  barman/p01</a:t>
             </a:r>
           </a:p>
         </p:txBody>
@@ -15605,12 +15605,13 @@
           <a:lstStyle/>
           <a:p>
             <a:r>
-              <a:rPr sz="1100">
+              <a:rPr sz="1000">
                 <a:solidFill>
-                  <a:srgbClr val="888888"/>
+                  <a:srgbClr val="111122"/>
                 </a:solidFill>
+                <a:latin typeface="Menlo"/>
               </a:rPr>
-              <a:t>(no simulate trials)</a:t>
+              <a:t>(empty response)</a:t>
             </a:r>
           </a:p>
         </p:txBody>
@@ -15660,7 +15661,7 @@
                   <a:srgbClr val="FFFFFF"/>
                 </a:solidFill>
               </a:rPr>
-              <a:t>Gemma4-26B-A4B · no simulate trials in this cell</a:t>
+              <a:t>Gemma4-26B-A4B  ·  failure_reason = truncated_no_answer  (285/300 simulate trials, 95%)  ·  barman/p01</a:t>
             </a:r>
           </a:p>
         </p:txBody>
@@ -15707,12 +15708,57 @@
           <a:lstStyle/>
           <a:p>
             <a:r>
-              <a:rPr sz="1100">
+              <a:rPr sz="1000">
                 <a:solidFill>
-                  <a:srgbClr val="888888"/>
+                  <a:srgbClr val="111122"/>
                 </a:solidFill>
+                <a:latin typeface="Menlo"/>
               </a:rPr>
-              <a:t>(no simulate trials)</a:t>
+              <a:t>thought</a:t>
+            </a:r>
+          </a:p>
+          <a:p>
+            <a:r>
+              <a:rPr sz="1000">
+                <a:solidFill>
+                  <a:srgbClr val="111122"/>
+                </a:solidFill>
+                <a:latin typeface="Menlo"/>
+              </a:rPr>
+              <a:t>*   `grasp(h, c)`: `ontable(c)` and `handempty(h)` $\rightarrow$ `not ontable(c)`, `not handempty(h)`, `holding(h, c)`.</a:t>
+            </a:r>
+          </a:p>
+          <a:p>
+            <a:r>
+              <a:rPr sz="1000">
+                <a:solidFill>
+                  <a:srgbClr val="111122"/>
+                </a:solidFill>
+                <a:latin typeface="Menlo"/>
+              </a:rPr>
+              <a:t>    *   `leave(h, c)`: `holding(h, c)` $\rightarrow$ `not holding(h, c)`, `handempty(h)`, `ontable(c)`.</a:t>
+            </a:r>
+          </a:p>
+          <a:p>
+            <a:r>
+              <a:rPr sz="1000">
+                <a:solidFill>
+                  <a:srgbClr val="111122"/>
+                </a:solidFill>
+                <a:latin typeface="Menlo"/>
+              </a:rPr>
+              <a:t>    *   `fill_shot(s, i, h1, h2, d)`: `holding(h1, s)`, `handempty(h2)`, `dispenses(d, i)`, `empty(s)`, `clean(s)` $\rightarrow$ `not empty(s)`, `contains(s, i)`, `not clean(s)`, `used(s, i)`.</a:t>
+            </a:r>
+          </a:p>
+          <a:p>
+            <a:r>
+              <a:rPr sz="1000">
+                <a:solidFill>
+                  <a:srgbClr val="111122"/>
+                </a:solidFill>
+                <a:latin typeface="Menlo"/>
+              </a:rPr>
+              <a:t>    *   `refill_shot(s, i, h1, h2, d)`: `holding(h1, s)`, `handempty(h2)`,</a:t>
             </a:r>
           </a:p>
         </p:txBody>

</xml_diff>